<commit_message>
Stage 8 review fixes: HO-004
</commit_message>
<xml_diff>
--- a/output/archive/Tarnovell_Group/Integration/Programme/2026/One_Group_Many_Practices_Steering_2026-09.pptx
+++ b/output/archive/Tarnovell_Group/Integration/Programme/2026/One_Group_Many_Practices_Steering_2026-09.pptx
@@ -4843,7 +4843,7 @@
                         <a:rPr sz="1400">
                           <a:latin typeface="Arial"/>
                         </a:rPr>
-                        <a:t>Completes 1 October 2026; archive held apart pending access and QA mapping</a:t>
+                        <a:t>Planned completion 1 October 2026; archive to remain held apart afterwards pending access and QA mapping</a:t>
                       </a:r>
                     </a:p>
                   </a:txBody>
@@ -5162,7 +5162,7 @@
               <a:rPr sz="2000">
                 <a:latin typeface="Arial"/>
               </a:rPr>
-              <a:t>Firm F, Durnesswick, is completing its migration; the remaining items are mostly legacy report headers and two signature blocks</a:t>
+              <a:t>Firm F, Durnesswick, is completing migration of current templates; legacy issued records retain their original appearance</a:t>
             </a:r>
           </a:p>
           <a:p>
@@ -5171,7 +5171,7 @@
               <a:rPr sz="2000">
                 <a:latin typeface="Arial"/>
               </a:rPr>
-              <a:t>Firm G, Osterquill, remains on its own legacy brand until it joins the group, and nothing is to be restyled before the archive has been reviewed</a:t>
+              <a:t>Osterquill remains independent ahead of planned 1 October 2026 completion; its legacy master will remain in use after completion pending onboarding</a:t>
             </a:r>
           </a:p>
           <a:p>
@@ -5714,7 +5714,7 @@
               <a:rPr sz="2000">
                 <a:latin typeface="Arial"/>
               </a:rPr>
-              <a:t>The common export dictionary is agreed and the fields in it are fixed for the first release</a:t>
+              <a:t>The common export dictionary is agreed as the mapping baseline; open reviewer comments must be resolved before release</a:t>
             </a:r>
           </a:p>
           <a:p>
@@ -5869,7 +5869,7 @@
                 </a:solidFill>
                 <a:latin typeface="Arial"/>
               </a:rPr>
-              <a:t>Osterquill: held apart until completion</a:t>
+              <a:t>Osterquill: planned completion and archive hold</a:t>
             </a:r>
           </a:p>
         </p:txBody>
@@ -5901,7 +5901,7 @@
               <a:rPr sz="2000">
                 <a:latin typeface="Arial"/>
               </a:rPr>
-              <a:t>Osterquill Toxicology completes its acquisition on 1 October 2026</a:t>
+              <a:t>Osterquill Toxicology is scheduled to join the group on 1 October 2026; completion has not occurred at this briefing date</a:t>
             </a:r>
           </a:p>
           <a:p>

</xml_diff>